<commit_message>
fix: dong bo ba cho con mang so lieu cu
* docs/slides/11-slides-ky-thuat.md — con ghi '~12 gio CPU'; so that tu
  results.csv la 10,05 gio. Bo slide 38 va quyen da sua tu truoc, rieng bo 11
  slide lot vi no duoc tao sau luot sua do.
* docs/papers/ch1-gioi-thieu.md (ban chinh) — con '882 test / 881 dat', la luot
  do 20/07. Ban compact da sua, ban chinh chua.
* README.md — hai cho ghi 1.001/1.000, nay la 1.002/1.001.

Kiem chung: pytest 1.001 dat 1 xfail 0 hong; check_slides 11 slide 0 loi;
check_thesis_refs 0 tham chieu chet o ca hai ban.

Co-Authored-By: Claude Opus 5 <noreply@anthropic.com>
</commit_message>
<xml_diff>
--- a/docs/slides/11-slides-ky-thuat.pptx
+++ b/docs/slides/11-slides-ky-thuat.pptx
@@ -46416,12 +46416,8 @@
                         <a:buNone/>
                       </a:pPr>
                       <a:r>
-                        <a:rPr/>
-                        <a:t>~12 giờ </a:t>
-                      </a:r>
-                      <a:r>
                         <a:rPr b="1"/>
-                        <a:t>CPU</a:t>
+                        <a:t>10,05 giờ CPU</a:t>
                       </a:r>
                     </a:p>
                   </a:txBody>

</xml_diff>

<commit_message>
build: dung lai pptx + docx sau cac dot sua md — tren mac, pandoc 3.10 arm64
- slides.pptx (deck bao ve), 11-slides, 12-slides-mon-hoc: rebuild tu md moi
- thesis-full.docx: rebuild
- nop/: dong bo lai 4 tep (pdf giu nguyen — xuat bang Word tren Windows)
- luu y: check_slides.ps1 van phai chay tren Windows (PowerPoint COM)
</commit_message>
<xml_diff>
--- a/docs/slides/11-slides-ky-thuat.pptx
+++ b/docs/slides/11-slides-ky-thuat.pptx
@@ -44670,7 +44670,25 @@
             <a:pPr lvl="0"/>
             <a:r>
               <a:rPr/>
-              <a:t>Benchmark ba engine OCR trên biển Việt Nam: PaddleOCR </a:t>
+              <a:t>Benchmark ba engine OCR trên bộ đo riêng của đồ án </a:t>
+            </a:r>
+            <a:r>
+              <a:rPr i="1"/>
+              <a:t>(chi tiết: </a:t>
+            </a:r>
+            <a:r>
+              <a:rPr i="1">
+                <a:latin typeface="Courier"/>
+              </a:rPr>
+              <a:t>36-engine-benchmark</a:t>
+            </a:r>
+            <a:r>
+              <a:rPr i="1"/>
+              <a:t>)</a:t>
+            </a:r>
+            <a:r>
+              <a:rPr/>
+              <a:t>: PaddleOCR </a:t>
             </a:r>
             <a:r>
               <a:rPr b="1"/>
@@ -44678,7 +44696,7 @@
             </a:r>
             <a:r>
               <a:rPr/>
-              <a:t> trong cấu hình đánh giá của đồ án; kết quả khác với khuynh hướng của một số tài liệu công khai</a:t>
+              <a:t>, hơn EasyOCR 54,59 điểm; kết quả khác với khuynh hướng của một số tài liệu công khai</a:t>
             </a:r>
           </a:p>
           <a:p>

</xml_diff>